<commit_message>
docs: update architecture presentation
Co-Authored-By: Claude Opus 4.6 (1M context) <noreply@anthropic.com>
</commit_message>
<xml_diff>
--- a/docs/self_improving_agent_architecture.pptx
+++ b/docs/self_improving_agent_architecture.pptx
@@ -5,21 +5,21 @@
     <p:sldMasterId id="2147483648" r:id="rId1"/>
   </p:sldMasterIdLst>
   <p:sldIdLst>
-    <p:sldId id="256" r:id="rId7"/>
-    <p:sldId id="257" r:id="rId8"/>
-    <p:sldId id="258" r:id="rId9"/>
-    <p:sldId id="259" r:id="rId10"/>
-    <p:sldId id="260" r:id="rId11"/>
-    <p:sldId id="261" r:id="rId12"/>
-    <p:sldId id="262" r:id="rId13"/>
-    <p:sldId id="263" r:id="rId14"/>
-    <p:sldId id="264" r:id="rId15"/>
-    <p:sldId id="265" r:id="rId16"/>
-    <p:sldId id="266" r:id="rId17"/>
-    <p:sldId id="267" r:id="rId18"/>
-    <p:sldId id="268" r:id="rId19"/>
+    <p:sldId id="256" r:id="rId2"/>
+    <p:sldId id="257" r:id="rId3"/>
+    <p:sldId id="258" r:id="rId4"/>
+    <p:sldId id="259" r:id="rId5"/>
+    <p:sldId id="260" r:id="rId6"/>
+    <p:sldId id="261" r:id="rId7"/>
+    <p:sldId id="262" r:id="rId8"/>
+    <p:sldId id="263" r:id="rId9"/>
+    <p:sldId id="264" r:id="rId10"/>
+    <p:sldId id="265" r:id="rId11"/>
+    <p:sldId id="266" r:id="rId12"/>
+    <p:sldId id="267" r:id="rId13"/>
+    <p:sldId id="268" r:id="rId14"/>
   </p:sldIdLst>
-  <p:sldSz cx="12191695" cy="6858000" type="screen4x3"/>
+  <p:sldSz cx="12192000" cy="6858000"/>
   <p:notesSz cx="6858000" cy="9144000"/>
   <p:defaultTextStyle>
     <a:defPPr>
@@ -116,6 +116,22 @@
       </a:defRPr>
     </a:lvl9pPr>
   </p:defaultTextStyle>
+  <p:extLst>
+    <p:ext uri="{EFAFB233-063F-42B5-8137-9DF3F51BA10A}">
+      <p15:sldGuideLst xmlns:p15="http://schemas.microsoft.com/office/powerpoint/2012/main">
+        <p15:guide id="1" orient="horz" pos="2160">
+          <p15:clr>
+            <a:srgbClr val="A4A3A4"/>
+          </p15:clr>
+        </p15:guide>
+        <p15:guide id="2" pos="2880">
+          <p15:clr>
+            <a:srgbClr val="A4A3A4"/>
+          </p15:clr>
+        </p15:guide>
+      </p15:sldGuideLst>
+    </p:ext>
+  </p:extLst>
 </p:presentation>
 </file>
 
@@ -157,10 +173,9 @@
           <a:lstStyle/>
           <a:p>
             <a:r>
-              <a:rPr lang="en-US" smtClean="0"/>
+              <a:rPr lang="en-US"/>
               <a:t>Click to edit Master title style</a:t>
             </a:r>
-            <a:endParaRPr lang="en-US"/>
           </a:p>
         </p:txBody>
       </p:sp>
@@ -276,10 +291,9 @@
           </a:lstStyle>
           <a:p>
             <a:r>
-              <a:rPr lang="en-US" smtClean="0"/>
+              <a:rPr lang="en-US"/>
               <a:t>Click to edit Master subtitle style</a:t>
             </a:r>
-            <a:endParaRPr lang="en-US"/>
           </a:p>
         </p:txBody>
       </p:sp>
@@ -300,7 +314,7 @@
           <a:p>
             <a:fld id="{5BCAD085-E8A6-8845-BD4E-CB4CCA059FC4}" type="datetimeFigureOut">
               <a:rPr lang="en-US" smtClean="0"/>
-              <a:t>1/27/13</a:t>
+              <a:t>4/6/26</a:t>
             </a:fld>
             <a:endParaRPr lang="en-US"/>
           </a:p>
@@ -394,10 +408,9 @@
           <a:lstStyle/>
           <a:p>
             <a:r>
-              <a:rPr lang="en-US" smtClean="0"/>
+              <a:rPr lang="en-US"/>
               <a:t>Click to edit Master title style</a:t>
             </a:r>
-            <a:endParaRPr lang="en-US"/>
           </a:p>
         </p:txBody>
       </p:sp>
@@ -418,38 +431,37 @@
           <a:p>
             <a:pPr lvl="0"/>
             <a:r>
-              <a:rPr lang="en-US" smtClean="0"/>
+              <a:rPr lang="en-US"/>
               <a:t>Click to edit Master text styles</a:t>
             </a:r>
           </a:p>
           <a:p>
             <a:pPr lvl="1"/>
             <a:r>
-              <a:rPr lang="en-US" smtClean="0"/>
+              <a:rPr lang="en-US"/>
               <a:t>Second level</a:t>
             </a:r>
           </a:p>
           <a:p>
             <a:pPr lvl="2"/>
             <a:r>
-              <a:rPr lang="en-US" smtClean="0"/>
+              <a:rPr lang="en-US"/>
               <a:t>Third level</a:t>
             </a:r>
           </a:p>
           <a:p>
             <a:pPr lvl="3"/>
             <a:r>
-              <a:rPr lang="en-US" smtClean="0"/>
+              <a:rPr lang="en-US"/>
               <a:t>Fourth level</a:t>
             </a:r>
           </a:p>
           <a:p>
             <a:pPr lvl="4"/>
             <a:r>
-              <a:rPr lang="en-US" smtClean="0"/>
+              <a:rPr lang="en-US"/>
               <a:t>Fifth level</a:t>
             </a:r>
-            <a:endParaRPr lang="en-US"/>
           </a:p>
         </p:txBody>
       </p:sp>
@@ -470,7 +482,7 @@
           <a:p>
             <a:fld id="{5BCAD085-E8A6-8845-BD4E-CB4CCA059FC4}" type="datetimeFigureOut">
               <a:rPr lang="en-US" smtClean="0"/>
-              <a:t>1/27/13</a:t>
+              <a:t>4/6/26</a:t>
             </a:fld>
             <a:endParaRPr lang="en-US"/>
           </a:p>
@@ -569,10 +581,9 @@
           <a:lstStyle/>
           <a:p>
             <a:r>
-              <a:rPr lang="en-US" smtClean="0"/>
+              <a:rPr lang="en-US"/>
               <a:t>Click to edit Master title style</a:t>
             </a:r>
-            <a:endParaRPr lang="en-US"/>
           </a:p>
         </p:txBody>
       </p:sp>
@@ -598,38 +609,37 @@
           <a:p>
             <a:pPr lvl="0"/>
             <a:r>
-              <a:rPr lang="en-US" smtClean="0"/>
+              <a:rPr lang="en-US"/>
               <a:t>Click to edit Master text styles</a:t>
             </a:r>
           </a:p>
           <a:p>
             <a:pPr lvl="1"/>
             <a:r>
-              <a:rPr lang="en-US" smtClean="0"/>
+              <a:rPr lang="en-US"/>
               <a:t>Second level</a:t>
             </a:r>
           </a:p>
           <a:p>
             <a:pPr lvl="2"/>
             <a:r>
-              <a:rPr lang="en-US" smtClean="0"/>
+              <a:rPr lang="en-US"/>
               <a:t>Third level</a:t>
             </a:r>
           </a:p>
           <a:p>
             <a:pPr lvl="3"/>
             <a:r>
-              <a:rPr lang="en-US" smtClean="0"/>
+              <a:rPr lang="en-US"/>
               <a:t>Fourth level</a:t>
             </a:r>
           </a:p>
           <a:p>
             <a:pPr lvl="4"/>
             <a:r>
-              <a:rPr lang="en-US" smtClean="0"/>
+              <a:rPr lang="en-US"/>
               <a:t>Fifth level</a:t>
             </a:r>
-            <a:endParaRPr lang="en-US"/>
           </a:p>
         </p:txBody>
       </p:sp>
@@ -650,7 +660,7 @@
           <a:p>
             <a:fld id="{5BCAD085-E8A6-8845-BD4E-CB4CCA059FC4}" type="datetimeFigureOut">
               <a:rPr lang="en-US" smtClean="0"/>
-              <a:t>1/27/13</a:t>
+              <a:t>4/6/26</a:t>
             </a:fld>
             <a:endParaRPr lang="en-US"/>
           </a:p>
@@ -744,10 +754,9 @@
           <a:lstStyle/>
           <a:p>
             <a:r>
-              <a:rPr lang="en-US" smtClean="0"/>
+              <a:rPr lang="en-US"/>
               <a:t>Click to edit Master title style</a:t>
             </a:r>
-            <a:endParaRPr lang="en-US"/>
           </a:p>
         </p:txBody>
       </p:sp>
@@ -768,38 +777,37 @@
           <a:p>
             <a:pPr lvl="0"/>
             <a:r>
-              <a:rPr lang="en-US" smtClean="0"/>
+              <a:rPr lang="en-US"/>
               <a:t>Click to edit Master text styles</a:t>
             </a:r>
           </a:p>
           <a:p>
             <a:pPr lvl="1"/>
             <a:r>
-              <a:rPr lang="en-US" smtClean="0"/>
+              <a:rPr lang="en-US"/>
               <a:t>Second level</a:t>
             </a:r>
           </a:p>
           <a:p>
             <a:pPr lvl="2"/>
             <a:r>
-              <a:rPr lang="en-US" smtClean="0"/>
+              <a:rPr lang="en-US"/>
               <a:t>Third level</a:t>
             </a:r>
           </a:p>
           <a:p>
             <a:pPr lvl="3"/>
             <a:r>
-              <a:rPr lang="en-US" smtClean="0"/>
+              <a:rPr lang="en-US"/>
               <a:t>Fourth level</a:t>
             </a:r>
           </a:p>
           <a:p>
             <a:pPr lvl="4"/>
             <a:r>
-              <a:rPr lang="en-US" smtClean="0"/>
+              <a:rPr lang="en-US"/>
               <a:t>Fifth level</a:t>
             </a:r>
-            <a:endParaRPr lang="en-US"/>
           </a:p>
         </p:txBody>
       </p:sp>
@@ -820,7 +828,7 @@
           <a:p>
             <a:fld id="{5BCAD085-E8A6-8845-BD4E-CB4CCA059FC4}" type="datetimeFigureOut">
               <a:rPr lang="en-US" smtClean="0"/>
-              <a:t>1/27/13</a:t>
+              <a:t>4/6/26</a:t>
             </a:fld>
             <a:endParaRPr lang="en-US"/>
           </a:p>
@@ -923,10 +931,9 @@
           </a:lstStyle>
           <a:p>
             <a:r>
-              <a:rPr lang="en-US" smtClean="0"/>
+              <a:rPr lang="en-US"/>
               <a:t>Click to edit Master title style</a:t>
             </a:r>
-            <a:endParaRPr lang="en-US"/>
           </a:p>
         </p:txBody>
       </p:sp>
@@ -1043,7 +1050,7 @@
           <a:p>
             <a:pPr lvl="0"/>
             <a:r>
-              <a:rPr lang="en-US" smtClean="0"/>
+              <a:rPr lang="en-US"/>
               <a:t>Click to edit Master text styles</a:t>
             </a:r>
           </a:p>
@@ -1066,7 +1073,7 @@
           <a:p>
             <a:fld id="{5BCAD085-E8A6-8845-BD4E-CB4CCA059FC4}" type="datetimeFigureOut">
               <a:rPr lang="en-US" smtClean="0"/>
-              <a:t>1/27/13</a:t>
+              <a:t>4/6/26</a:t>
             </a:fld>
             <a:endParaRPr lang="en-US"/>
           </a:p>
@@ -1160,10 +1167,9 @@
           <a:lstStyle/>
           <a:p>
             <a:r>
-              <a:rPr lang="en-US" smtClean="0"/>
+              <a:rPr lang="en-US"/>
               <a:t>Click to edit Master title style</a:t>
             </a:r>
-            <a:endParaRPr lang="en-US"/>
           </a:p>
         </p:txBody>
       </p:sp>
@@ -1217,38 +1223,37 @@
           <a:p>
             <a:pPr lvl="0"/>
             <a:r>
-              <a:rPr lang="en-US" smtClean="0"/>
+              <a:rPr lang="en-US"/>
               <a:t>Click to edit Master text styles</a:t>
             </a:r>
           </a:p>
           <a:p>
             <a:pPr lvl="1"/>
             <a:r>
-              <a:rPr lang="en-US" smtClean="0"/>
+              <a:rPr lang="en-US"/>
               <a:t>Second level</a:t>
             </a:r>
           </a:p>
           <a:p>
             <a:pPr lvl="2"/>
             <a:r>
-              <a:rPr lang="en-US" smtClean="0"/>
+              <a:rPr lang="en-US"/>
               <a:t>Third level</a:t>
             </a:r>
           </a:p>
           <a:p>
             <a:pPr lvl="3"/>
             <a:r>
-              <a:rPr lang="en-US" smtClean="0"/>
+              <a:rPr lang="en-US"/>
               <a:t>Fourth level</a:t>
             </a:r>
           </a:p>
           <a:p>
             <a:pPr lvl="4"/>
             <a:r>
-              <a:rPr lang="en-US" smtClean="0"/>
+              <a:rPr lang="en-US"/>
               <a:t>Fifth level</a:t>
             </a:r>
-            <a:endParaRPr lang="en-US"/>
           </a:p>
         </p:txBody>
       </p:sp>
@@ -1302,38 +1307,37 @@
           <a:p>
             <a:pPr lvl="0"/>
             <a:r>
-              <a:rPr lang="en-US" smtClean="0"/>
+              <a:rPr lang="en-US"/>
               <a:t>Click to edit Master text styles</a:t>
             </a:r>
           </a:p>
           <a:p>
             <a:pPr lvl="1"/>
             <a:r>
-              <a:rPr lang="en-US" smtClean="0"/>
+              <a:rPr lang="en-US"/>
               <a:t>Second level</a:t>
             </a:r>
           </a:p>
           <a:p>
             <a:pPr lvl="2"/>
             <a:r>
-              <a:rPr lang="en-US" smtClean="0"/>
+              <a:rPr lang="en-US"/>
               <a:t>Third level</a:t>
             </a:r>
           </a:p>
           <a:p>
             <a:pPr lvl="3"/>
             <a:r>
-              <a:rPr lang="en-US" smtClean="0"/>
+              <a:rPr lang="en-US"/>
               <a:t>Fourth level</a:t>
             </a:r>
           </a:p>
           <a:p>
             <a:pPr lvl="4"/>
             <a:r>
-              <a:rPr lang="en-US" smtClean="0"/>
+              <a:rPr lang="en-US"/>
               <a:t>Fifth level</a:t>
             </a:r>
-            <a:endParaRPr lang="en-US"/>
           </a:p>
         </p:txBody>
       </p:sp>
@@ -1354,7 +1358,7 @@
           <a:p>
             <a:fld id="{5BCAD085-E8A6-8845-BD4E-CB4CCA059FC4}" type="datetimeFigureOut">
               <a:rPr lang="en-US" smtClean="0"/>
-              <a:t>1/27/13</a:t>
+              <a:t>4/6/26</a:t>
             </a:fld>
             <a:endParaRPr lang="en-US"/>
           </a:p>
@@ -1452,10 +1456,9 @@
           </a:lstStyle>
           <a:p>
             <a:r>
-              <a:rPr lang="en-US" smtClean="0"/>
+              <a:rPr lang="en-US"/>
               <a:t>Click to edit Master title style</a:t>
             </a:r>
-            <a:endParaRPr lang="en-US"/>
           </a:p>
         </p:txBody>
       </p:sp>
@@ -1518,7 +1521,7 @@
           <a:p>
             <a:pPr lvl="0"/>
             <a:r>
-              <a:rPr lang="en-US" smtClean="0"/>
+              <a:rPr lang="en-US"/>
               <a:t>Click to edit Master text styles</a:t>
             </a:r>
           </a:p>
@@ -1574,38 +1577,37 @@
           <a:p>
             <a:pPr lvl="0"/>
             <a:r>
-              <a:rPr lang="en-US" smtClean="0"/>
+              <a:rPr lang="en-US"/>
               <a:t>Click to edit Master text styles</a:t>
             </a:r>
           </a:p>
           <a:p>
             <a:pPr lvl="1"/>
             <a:r>
-              <a:rPr lang="en-US" smtClean="0"/>
+              <a:rPr lang="en-US"/>
               <a:t>Second level</a:t>
             </a:r>
           </a:p>
           <a:p>
             <a:pPr lvl="2"/>
             <a:r>
-              <a:rPr lang="en-US" smtClean="0"/>
+              <a:rPr lang="en-US"/>
               <a:t>Third level</a:t>
             </a:r>
           </a:p>
           <a:p>
             <a:pPr lvl="3"/>
             <a:r>
-              <a:rPr lang="en-US" smtClean="0"/>
+              <a:rPr lang="en-US"/>
               <a:t>Fourth level</a:t>
             </a:r>
           </a:p>
           <a:p>
             <a:pPr lvl="4"/>
             <a:r>
-              <a:rPr lang="en-US" smtClean="0"/>
+              <a:rPr lang="en-US"/>
               <a:t>Fifth level</a:t>
             </a:r>
-            <a:endParaRPr lang="en-US"/>
           </a:p>
         </p:txBody>
       </p:sp>
@@ -1668,7 +1670,7 @@
           <a:p>
             <a:pPr lvl="0"/>
             <a:r>
-              <a:rPr lang="en-US" smtClean="0"/>
+              <a:rPr lang="en-US"/>
               <a:t>Click to edit Master text styles</a:t>
             </a:r>
           </a:p>
@@ -1724,38 +1726,37 @@
           <a:p>
             <a:pPr lvl="0"/>
             <a:r>
-              <a:rPr lang="en-US" smtClean="0"/>
+              <a:rPr lang="en-US"/>
               <a:t>Click to edit Master text styles</a:t>
             </a:r>
           </a:p>
           <a:p>
             <a:pPr lvl="1"/>
             <a:r>
-              <a:rPr lang="en-US" smtClean="0"/>
+              <a:rPr lang="en-US"/>
               <a:t>Second level</a:t>
             </a:r>
           </a:p>
           <a:p>
             <a:pPr lvl="2"/>
             <a:r>
-              <a:rPr lang="en-US" smtClean="0"/>
+              <a:rPr lang="en-US"/>
               <a:t>Third level</a:t>
             </a:r>
           </a:p>
           <a:p>
             <a:pPr lvl="3"/>
             <a:r>
-              <a:rPr lang="en-US" smtClean="0"/>
+              <a:rPr lang="en-US"/>
               <a:t>Fourth level</a:t>
             </a:r>
           </a:p>
           <a:p>
             <a:pPr lvl="4"/>
             <a:r>
-              <a:rPr lang="en-US" smtClean="0"/>
+              <a:rPr lang="en-US"/>
               <a:t>Fifth level</a:t>
             </a:r>
-            <a:endParaRPr lang="en-US"/>
           </a:p>
         </p:txBody>
       </p:sp>
@@ -1776,7 +1777,7 @@
           <a:p>
             <a:fld id="{5BCAD085-E8A6-8845-BD4E-CB4CCA059FC4}" type="datetimeFigureOut">
               <a:rPr lang="en-US" smtClean="0"/>
-              <a:t>1/27/13</a:t>
+              <a:t>4/6/26</a:t>
             </a:fld>
             <a:endParaRPr lang="en-US"/>
           </a:p>
@@ -1870,10 +1871,9 @@
           <a:lstStyle/>
           <a:p>
             <a:r>
-              <a:rPr lang="en-US" smtClean="0"/>
+              <a:rPr lang="en-US"/>
               <a:t>Click to edit Master title style</a:t>
             </a:r>
-            <a:endParaRPr lang="en-US"/>
           </a:p>
         </p:txBody>
       </p:sp>
@@ -1894,7 +1894,7 @@
           <a:p>
             <a:fld id="{5BCAD085-E8A6-8845-BD4E-CB4CCA059FC4}" type="datetimeFigureOut">
               <a:rPr lang="en-US" smtClean="0"/>
-              <a:t>1/27/13</a:t>
+              <a:t>4/6/26</a:t>
             </a:fld>
             <a:endParaRPr lang="en-US"/>
           </a:p>
@@ -1989,7 +1989,7 @@
           <a:p>
             <a:fld id="{5BCAD085-E8A6-8845-BD4E-CB4CCA059FC4}" type="datetimeFigureOut">
               <a:rPr lang="en-US" smtClean="0"/>
-              <a:t>1/27/13</a:t>
+              <a:t>4/6/26</a:t>
             </a:fld>
             <a:endParaRPr lang="en-US"/>
           </a:p>
@@ -2092,10 +2092,9 @@
           </a:lstStyle>
           <a:p>
             <a:r>
-              <a:rPr lang="en-US" smtClean="0"/>
+              <a:rPr lang="en-US"/>
               <a:t>Click to edit Master title style</a:t>
             </a:r>
-            <a:endParaRPr lang="en-US"/>
           </a:p>
         </p:txBody>
       </p:sp>
@@ -2149,38 +2148,37 @@
           <a:p>
             <a:pPr lvl="0"/>
             <a:r>
-              <a:rPr lang="en-US" smtClean="0"/>
+              <a:rPr lang="en-US"/>
               <a:t>Click to edit Master text styles</a:t>
             </a:r>
           </a:p>
           <a:p>
             <a:pPr lvl="1"/>
             <a:r>
-              <a:rPr lang="en-US" smtClean="0"/>
+              <a:rPr lang="en-US"/>
               <a:t>Second level</a:t>
             </a:r>
           </a:p>
           <a:p>
             <a:pPr lvl="2"/>
             <a:r>
-              <a:rPr lang="en-US" smtClean="0"/>
+              <a:rPr lang="en-US"/>
               <a:t>Third level</a:t>
             </a:r>
           </a:p>
           <a:p>
             <a:pPr lvl="3"/>
             <a:r>
-              <a:rPr lang="en-US" smtClean="0"/>
+              <a:rPr lang="en-US"/>
               <a:t>Fourth level</a:t>
             </a:r>
           </a:p>
           <a:p>
             <a:pPr lvl="4"/>
             <a:r>
-              <a:rPr lang="en-US" smtClean="0"/>
+              <a:rPr lang="en-US"/>
               <a:t>Fifth level</a:t>
             </a:r>
-            <a:endParaRPr lang="en-US"/>
           </a:p>
         </p:txBody>
       </p:sp>
@@ -2243,7 +2241,7 @@
           <a:p>
             <a:pPr lvl="0"/>
             <a:r>
-              <a:rPr lang="en-US" smtClean="0"/>
+              <a:rPr lang="en-US"/>
               <a:t>Click to edit Master text styles</a:t>
             </a:r>
           </a:p>
@@ -2266,7 +2264,7 @@
           <a:p>
             <a:fld id="{5BCAD085-E8A6-8845-BD4E-CB4CCA059FC4}" type="datetimeFigureOut">
               <a:rPr lang="en-US" smtClean="0"/>
-              <a:t>1/27/13</a:t>
+              <a:t>4/6/26</a:t>
             </a:fld>
             <a:endParaRPr lang="en-US"/>
           </a:p>
@@ -2369,10 +2367,9 @@
           </a:lstStyle>
           <a:p>
             <a:r>
-              <a:rPr lang="en-US" smtClean="0"/>
+              <a:rPr lang="en-US"/>
               <a:t>Click to edit Master title style</a:t>
             </a:r>
-            <a:endParaRPr lang="en-US"/>
           </a:p>
         </p:txBody>
       </p:sp>
@@ -2496,7 +2493,7 @@
           <a:p>
             <a:pPr lvl="0"/>
             <a:r>
-              <a:rPr lang="en-US" smtClean="0"/>
+              <a:rPr lang="en-US"/>
               <a:t>Click to edit Master text styles</a:t>
             </a:r>
           </a:p>
@@ -2519,7 +2516,7 @@
           <a:p>
             <a:fld id="{5BCAD085-E8A6-8845-BD4E-CB4CCA059FC4}" type="datetimeFigureOut">
               <a:rPr lang="en-US" smtClean="0"/>
-              <a:t>1/27/13</a:t>
+              <a:t>4/6/26</a:t>
             </a:fld>
             <a:endParaRPr lang="en-US"/>
           </a:p>
@@ -2628,10 +2625,9 @@
           <a:lstStyle/>
           <a:p>
             <a:r>
-              <a:rPr lang="en-US" smtClean="0"/>
+              <a:rPr lang="en-US"/>
               <a:t>Click to edit Master title style</a:t>
             </a:r>
-            <a:endParaRPr lang="en-US"/>
           </a:p>
         </p:txBody>
       </p:sp>
@@ -2662,38 +2658,37 @@
           <a:p>
             <a:pPr lvl="0"/>
             <a:r>
-              <a:rPr lang="en-US" smtClean="0"/>
+              <a:rPr lang="en-US"/>
               <a:t>Click to edit Master text styles</a:t>
             </a:r>
           </a:p>
           <a:p>
             <a:pPr lvl="1"/>
             <a:r>
-              <a:rPr lang="en-US" smtClean="0"/>
+              <a:rPr lang="en-US"/>
               <a:t>Second level</a:t>
             </a:r>
           </a:p>
           <a:p>
             <a:pPr lvl="2"/>
             <a:r>
-              <a:rPr lang="en-US" smtClean="0"/>
+              <a:rPr lang="en-US"/>
               <a:t>Third level</a:t>
             </a:r>
           </a:p>
           <a:p>
             <a:pPr lvl="3"/>
             <a:r>
-              <a:rPr lang="en-US" smtClean="0"/>
+              <a:rPr lang="en-US"/>
               <a:t>Fourth level</a:t>
             </a:r>
           </a:p>
           <a:p>
             <a:pPr lvl="4"/>
             <a:r>
-              <a:rPr lang="en-US" smtClean="0"/>
+              <a:rPr lang="en-US"/>
               <a:t>Fifth level</a:t>
             </a:r>
-            <a:endParaRPr lang="en-US"/>
           </a:p>
         </p:txBody>
       </p:sp>
@@ -2732,7 +2727,7 @@
           <a:p>
             <a:fld id="{5BCAD085-E8A6-8845-BD4E-CB4CCA059FC4}" type="datetimeFigureOut">
               <a:rPr lang="en-US" smtClean="0"/>
-              <a:t>1/27/13</a:t>
+              <a:t>4/6/26</a:t>
             </a:fld>
             <a:endParaRPr lang="en-US"/>
           </a:p>
@@ -3091,7 +3086,7 @@
 </file>
 
 <file path=ppt/slides/slide1.xml><?xml version="1.0" encoding="utf-8"?>
-<p:sld xmlns:a="http://schemas.openxmlformats.org/drawingml/2006/main" xmlns:p="http://schemas.openxmlformats.org/presentationml/2006/main" xmlns:r="http://schemas.openxmlformats.org/officeDocument/2006/relationships">
+<p:sld xmlns:a="http://schemas.openxmlformats.org/drawingml/2006/main" xmlns:r="http://schemas.openxmlformats.org/officeDocument/2006/relationships" xmlns:p="http://schemas.openxmlformats.org/presentationml/2006/main">
   <p:cSld>
     <p:bg>
       <p:bgPr>
@@ -3107,7 +3102,14 @@
         <p:cNvGrpSpPr/>
         <p:nvPr/>
       </p:nvGrpSpPr>
-      <p:grpSpPr/>
+      <p:grpSpPr>
+        <a:xfrm>
+          <a:off x="0" y="0"/>
+          <a:ext cx="0" cy="0"/>
+          <a:chOff x="0" y="0"/>
+          <a:chExt cx="0" cy="0"/>
+        </a:xfrm>
+      </p:grpSpPr>
       <p:sp>
         <p:nvSpPr>
           <p:cNvPr id="2" name="Rectangle 1"/>
@@ -3150,6 +3152,7 @@
           <a:lstStyle/>
           <a:p>
             <a:pPr algn="ctr"/>
+            <a:endParaRPr/>
           </a:p>
         </p:txBody>
       </p:sp>
@@ -3251,7 +3254,6 @@
             </a:r>
           </a:p>
           <a:p>
-            <a:pPr/>
             <a:r>
               <a:rPr sz="1100">
                 <a:solidFill>
@@ -3263,7 +3265,6 @@
             </a:r>
           </a:p>
           <a:p>
-            <a:pPr/>
             <a:r>
               <a:rPr sz="1100">
                 <a:solidFill>
@@ -3275,7 +3276,6 @@
             </a:r>
           </a:p>
           <a:p>
-            <a:pPr/>
             <a:r>
               <a:rPr sz="1100">
                 <a:solidFill>
@@ -3341,7 +3341,6 @@
             </a:r>
           </a:p>
           <a:p>
-            <a:pPr/>
             <a:r>
               <a:rPr sz="1100">
                 <a:solidFill>
@@ -3353,7 +3352,6 @@
             </a:r>
           </a:p>
           <a:p>
-            <a:pPr/>
             <a:r>
               <a:rPr sz="1100">
                 <a:solidFill>
@@ -3365,7 +3363,6 @@
             </a:r>
           </a:p>
           <a:p>
-            <a:pPr/>
             <a:r>
               <a:rPr sz="1100">
                 <a:solidFill>
@@ -3431,7 +3428,6 @@
             </a:r>
           </a:p>
           <a:p>
-            <a:pPr/>
             <a:r>
               <a:rPr sz="1100">
                 <a:solidFill>
@@ -3443,7 +3439,6 @@
             </a:r>
           </a:p>
           <a:p>
-            <a:pPr/>
             <a:r>
               <a:rPr sz="1100">
                 <a:solidFill>
@@ -3455,7 +3450,6 @@
             </a:r>
           </a:p>
           <a:p>
-            <a:pPr/>
             <a:r>
               <a:rPr sz="1100">
                 <a:solidFill>
@@ -3512,7 +3506,7 @@
 </file>
 
 <file path=ppt/slides/slide10.xml><?xml version="1.0" encoding="utf-8"?>
-<p:sld xmlns:a="http://schemas.openxmlformats.org/drawingml/2006/main" xmlns:p="http://schemas.openxmlformats.org/presentationml/2006/main" xmlns:r="http://schemas.openxmlformats.org/officeDocument/2006/relationships">
+<p:sld xmlns:a="http://schemas.openxmlformats.org/drawingml/2006/main" xmlns:r="http://schemas.openxmlformats.org/officeDocument/2006/relationships" xmlns:p="http://schemas.openxmlformats.org/presentationml/2006/main">
   <p:cSld>
     <p:bg>
       <p:bgPr>
@@ -3528,7 +3522,14 @@
         <p:cNvGrpSpPr/>
         <p:nvPr/>
       </p:nvGrpSpPr>
-      <p:grpSpPr/>
+      <p:grpSpPr>
+        <a:xfrm>
+          <a:off x="0" y="0"/>
+          <a:ext cx="0" cy="0"/>
+          <a:chOff x="0" y="0"/>
+          <a:chExt cx="0" cy="0"/>
+        </a:xfrm>
+      </p:grpSpPr>
       <p:sp>
         <p:nvSpPr>
           <p:cNvPr id="2" name="TextBox 1"/>
@@ -3616,6 +3617,7 @@
           <a:lstStyle/>
           <a:p>
             <a:pPr algn="ctr"/>
+            <a:endParaRPr/>
           </a:p>
         </p:txBody>
       </p:sp>
@@ -3774,6 +3776,7 @@
           <a:lstStyle/>
           <a:p>
             <a:pPr algn="ctr"/>
+            <a:endParaRPr/>
           </a:p>
         </p:txBody>
       </p:sp>
@@ -3932,6 +3935,7 @@
           <a:lstStyle/>
           <a:p>
             <a:pPr algn="ctr"/>
+            <a:endParaRPr/>
           </a:p>
         </p:txBody>
       </p:sp>
@@ -4156,7 +4160,7 @@
 </file>
 
 <file path=ppt/slides/slide11.xml><?xml version="1.0" encoding="utf-8"?>
-<p:sld xmlns:a="http://schemas.openxmlformats.org/drawingml/2006/main" xmlns:p="http://schemas.openxmlformats.org/presentationml/2006/main" xmlns:r="http://schemas.openxmlformats.org/officeDocument/2006/relationships">
+<p:sld xmlns:a="http://schemas.openxmlformats.org/drawingml/2006/main" xmlns:r="http://schemas.openxmlformats.org/officeDocument/2006/relationships" xmlns:p="http://schemas.openxmlformats.org/presentationml/2006/main">
   <p:cSld>
     <p:bg>
       <p:bgPr>
@@ -4172,7 +4176,14 @@
         <p:cNvGrpSpPr/>
         <p:nvPr/>
       </p:nvGrpSpPr>
-      <p:grpSpPr/>
+      <p:grpSpPr>
+        <a:xfrm>
+          <a:off x="0" y="0"/>
+          <a:ext cx="0" cy="0"/>
+          <a:chOff x="0" y="0"/>
+          <a:chExt cx="0" cy="0"/>
+        </a:xfrm>
+      </p:grpSpPr>
       <p:sp>
         <p:nvSpPr>
           <p:cNvPr id="2" name="TextBox 1"/>
@@ -4260,6 +4271,7 @@
           <a:lstStyle/>
           <a:p>
             <a:pPr algn="ctr"/>
+            <a:endParaRPr/>
           </a:p>
         </p:txBody>
       </p:sp>
@@ -4430,6 +4442,7 @@
           <a:lstStyle/>
           <a:p>
             <a:pPr algn="ctr"/>
+            <a:endParaRPr/>
           </a:p>
         </p:txBody>
       </p:sp>
@@ -4576,6 +4589,7 @@
           <a:lstStyle/>
           <a:p>
             <a:pPr algn="ctr"/>
+            <a:endParaRPr/>
           </a:p>
         </p:txBody>
       </p:sp>
@@ -4778,7 +4792,7 @@
 </file>
 
 <file path=ppt/slides/slide12.xml><?xml version="1.0" encoding="utf-8"?>
-<p:sld xmlns:a="http://schemas.openxmlformats.org/drawingml/2006/main" xmlns:p="http://schemas.openxmlformats.org/presentationml/2006/main" xmlns:r="http://schemas.openxmlformats.org/officeDocument/2006/relationships">
+<p:sld xmlns:a="http://schemas.openxmlformats.org/drawingml/2006/main" xmlns:r="http://schemas.openxmlformats.org/officeDocument/2006/relationships" xmlns:p="http://schemas.openxmlformats.org/presentationml/2006/main">
   <p:cSld>
     <p:bg>
       <p:bgPr>
@@ -4794,7 +4808,14 @@
         <p:cNvGrpSpPr/>
         <p:nvPr/>
       </p:nvGrpSpPr>
-      <p:grpSpPr/>
+      <p:grpSpPr>
+        <a:xfrm>
+          <a:off x="0" y="0"/>
+          <a:ext cx="0" cy="0"/>
+          <a:chOff x="0" y="0"/>
+          <a:chExt cx="0" cy="0"/>
+        </a:xfrm>
+      </p:grpSpPr>
       <p:sp>
         <p:nvSpPr>
           <p:cNvPr id="2" name="TextBox 1"/>
@@ -4882,6 +4903,7 @@
           <a:lstStyle/>
           <a:p>
             <a:pPr algn="ctr"/>
+            <a:endParaRPr/>
           </a:p>
         </p:txBody>
       </p:sp>
@@ -4986,15 +5008,12 @@
           </a:p>
           <a:p>
             <a:pPr algn="l"/>
-            <a:r>
-              <a:rPr sz="1050">
-                <a:solidFill>
-                  <a:srgbClr val="1F2937"/>
-                </a:solidFill>
-                <a:latin typeface="Aptos"/>
-              </a:rPr>
-              <a:t/>
-            </a:r>
+            <a:endParaRPr sz="1050">
+              <a:solidFill>
+                <a:srgbClr val="1F2937"/>
+              </a:solidFill>
+              <a:latin typeface="Aptos"/>
+            </a:endParaRPr>
           </a:p>
           <a:p>
             <a:pPr algn="l"/>
@@ -5022,15 +5041,12 @@
           </a:p>
           <a:p>
             <a:pPr algn="l"/>
-            <a:r>
-              <a:rPr sz="1050">
-                <a:solidFill>
-                  <a:srgbClr val="1F2937"/>
-                </a:solidFill>
-                <a:latin typeface="Aptos"/>
-              </a:rPr>
-              <a:t/>
-            </a:r>
+            <a:endParaRPr sz="1050">
+              <a:solidFill>
+                <a:srgbClr val="1F2937"/>
+              </a:solidFill>
+              <a:latin typeface="Aptos"/>
+            </a:endParaRPr>
           </a:p>
           <a:p>
             <a:pPr algn="l"/>
@@ -5058,15 +5074,12 @@
           </a:p>
           <a:p>
             <a:pPr algn="l"/>
-            <a:r>
-              <a:rPr sz="1050">
-                <a:solidFill>
-                  <a:srgbClr val="1F2937"/>
-                </a:solidFill>
-                <a:latin typeface="Aptos"/>
-              </a:rPr>
-              <a:t/>
-            </a:r>
+            <a:endParaRPr sz="1050">
+              <a:solidFill>
+                <a:srgbClr val="1F2937"/>
+              </a:solidFill>
+              <a:latin typeface="Aptos"/>
+            </a:endParaRPr>
           </a:p>
           <a:p>
             <a:pPr algn="l"/>
@@ -5094,15 +5107,12 @@
           </a:p>
           <a:p>
             <a:pPr algn="l"/>
-            <a:r>
-              <a:rPr sz="1050">
-                <a:solidFill>
-                  <a:srgbClr val="1F2937"/>
-                </a:solidFill>
-                <a:latin typeface="Aptos"/>
-              </a:rPr>
-              <a:t/>
-            </a:r>
+            <a:endParaRPr sz="1050">
+              <a:solidFill>
+                <a:srgbClr val="1F2937"/>
+              </a:solidFill>
+              <a:latin typeface="Aptos"/>
+            </a:endParaRPr>
           </a:p>
           <a:p>
             <a:pPr algn="l"/>
@@ -5130,15 +5140,12 @@
           </a:p>
           <a:p>
             <a:pPr algn="l"/>
-            <a:r>
-              <a:rPr sz="1050">
-                <a:solidFill>
-                  <a:srgbClr val="1F2937"/>
-                </a:solidFill>
-                <a:latin typeface="Aptos"/>
-              </a:rPr>
-              <a:t/>
-            </a:r>
+            <a:endParaRPr sz="1050">
+              <a:solidFill>
+                <a:srgbClr val="1F2937"/>
+              </a:solidFill>
+              <a:latin typeface="Aptos"/>
+            </a:endParaRPr>
           </a:p>
           <a:p>
             <a:pPr algn="l"/>
@@ -5166,15 +5173,12 @@
           </a:p>
           <a:p>
             <a:pPr algn="l"/>
-            <a:r>
-              <a:rPr sz="1050">
-                <a:solidFill>
-                  <a:srgbClr val="1F2937"/>
-                </a:solidFill>
-                <a:latin typeface="Aptos"/>
-              </a:rPr>
-              <a:t/>
-            </a:r>
+            <a:endParaRPr sz="1050">
+              <a:solidFill>
+                <a:srgbClr val="1F2937"/>
+              </a:solidFill>
+              <a:latin typeface="Aptos"/>
+            </a:endParaRPr>
           </a:p>
           <a:p>
             <a:pPr algn="l"/>
@@ -5244,6 +5248,7 @@
           <a:lstStyle/>
           <a:p>
             <a:pPr algn="ctr"/>
+            <a:endParaRPr/>
           </a:p>
         </p:txBody>
       </p:sp>
@@ -5348,15 +5353,12 @@
           </a:p>
           <a:p>
             <a:pPr algn="l"/>
-            <a:r>
-              <a:rPr sz="1050">
-                <a:solidFill>
-                  <a:srgbClr val="1F2937"/>
-                </a:solidFill>
-                <a:latin typeface="Aptos"/>
-              </a:rPr>
-              <a:t/>
-            </a:r>
+            <a:endParaRPr sz="1050">
+              <a:solidFill>
+                <a:srgbClr val="1F2937"/>
+              </a:solidFill>
+              <a:latin typeface="Aptos"/>
+            </a:endParaRPr>
           </a:p>
           <a:p>
             <a:pPr algn="l"/>
@@ -5384,15 +5386,12 @@
           </a:p>
           <a:p>
             <a:pPr algn="l"/>
-            <a:r>
-              <a:rPr sz="1050">
-                <a:solidFill>
-                  <a:srgbClr val="1F2937"/>
-                </a:solidFill>
-                <a:latin typeface="Aptos"/>
-              </a:rPr>
-              <a:t/>
-            </a:r>
+            <a:endParaRPr sz="1050">
+              <a:solidFill>
+                <a:srgbClr val="1F2937"/>
+              </a:solidFill>
+              <a:latin typeface="Aptos"/>
+            </a:endParaRPr>
           </a:p>
           <a:p>
             <a:pPr algn="l"/>
@@ -5420,15 +5419,12 @@
           </a:p>
           <a:p>
             <a:pPr algn="l"/>
-            <a:r>
-              <a:rPr sz="1050">
-                <a:solidFill>
-                  <a:srgbClr val="1F2937"/>
-                </a:solidFill>
-                <a:latin typeface="Aptos"/>
-              </a:rPr>
-              <a:t/>
-            </a:r>
+            <a:endParaRPr sz="1050">
+              <a:solidFill>
+                <a:srgbClr val="1F2937"/>
+              </a:solidFill>
+              <a:latin typeface="Aptos"/>
+            </a:endParaRPr>
           </a:p>
           <a:p>
             <a:pPr algn="l"/>
@@ -5456,15 +5452,12 @@
           </a:p>
           <a:p>
             <a:pPr algn="l"/>
-            <a:r>
-              <a:rPr sz="1050">
-                <a:solidFill>
-                  <a:srgbClr val="1F2937"/>
-                </a:solidFill>
-                <a:latin typeface="Aptos"/>
-              </a:rPr>
-              <a:t/>
-            </a:r>
+            <a:endParaRPr sz="1050">
+              <a:solidFill>
+                <a:srgbClr val="1F2937"/>
+              </a:solidFill>
+              <a:latin typeface="Aptos"/>
+            </a:endParaRPr>
           </a:p>
           <a:p>
             <a:pPr algn="l"/>
@@ -5492,15 +5485,12 @@
           </a:p>
           <a:p>
             <a:pPr algn="l"/>
-            <a:r>
-              <a:rPr sz="1050">
-                <a:solidFill>
-                  <a:srgbClr val="1F2937"/>
-                </a:solidFill>
-                <a:latin typeface="Aptos"/>
-              </a:rPr>
-              <a:t/>
-            </a:r>
+            <a:endParaRPr sz="1050">
+              <a:solidFill>
+                <a:srgbClr val="1F2937"/>
+              </a:solidFill>
+              <a:latin typeface="Aptos"/>
+            </a:endParaRPr>
           </a:p>
           <a:p>
             <a:pPr algn="l"/>
@@ -5570,6 +5560,7 @@
           <a:lstStyle/>
           <a:p>
             <a:pPr algn="ctr"/>
+            <a:endParaRPr/>
           </a:p>
         </p:txBody>
       </p:sp>
@@ -5674,15 +5665,12 @@
           </a:p>
           <a:p>
             <a:pPr algn="l"/>
-            <a:r>
-              <a:rPr sz="1050">
-                <a:solidFill>
-                  <a:srgbClr val="1F2937"/>
-                </a:solidFill>
-                <a:latin typeface="Aptos"/>
-              </a:rPr>
-              <a:t/>
-            </a:r>
+            <a:endParaRPr sz="1050">
+              <a:solidFill>
+                <a:srgbClr val="1F2937"/>
+              </a:solidFill>
+              <a:latin typeface="Aptos"/>
+            </a:endParaRPr>
           </a:p>
           <a:p>
             <a:pPr algn="l"/>
@@ -5710,15 +5698,12 @@
           </a:p>
           <a:p>
             <a:pPr algn="l"/>
-            <a:r>
-              <a:rPr sz="1050">
-                <a:solidFill>
-                  <a:srgbClr val="1F2937"/>
-                </a:solidFill>
-                <a:latin typeface="Aptos"/>
-              </a:rPr>
-              <a:t/>
-            </a:r>
+            <a:endParaRPr sz="1050">
+              <a:solidFill>
+                <a:srgbClr val="1F2937"/>
+              </a:solidFill>
+              <a:latin typeface="Aptos"/>
+            </a:endParaRPr>
           </a:p>
           <a:p>
             <a:pPr algn="l"/>
@@ -5746,15 +5731,12 @@
           </a:p>
           <a:p>
             <a:pPr algn="l"/>
-            <a:r>
-              <a:rPr sz="1050">
-                <a:solidFill>
-                  <a:srgbClr val="1F2937"/>
-                </a:solidFill>
-                <a:latin typeface="Aptos"/>
-              </a:rPr>
-              <a:t/>
-            </a:r>
+            <a:endParaRPr sz="1050">
+              <a:solidFill>
+                <a:srgbClr val="1F2937"/>
+              </a:solidFill>
+              <a:latin typeface="Aptos"/>
+            </a:endParaRPr>
           </a:p>
           <a:p>
             <a:pPr algn="l"/>
@@ -5782,15 +5764,12 @@
           </a:p>
           <a:p>
             <a:pPr algn="l"/>
-            <a:r>
-              <a:rPr sz="1050">
-                <a:solidFill>
-                  <a:srgbClr val="1F2937"/>
-                </a:solidFill>
-                <a:latin typeface="Aptos"/>
-              </a:rPr>
-              <a:t/>
-            </a:r>
+            <a:endParaRPr sz="1050">
+              <a:solidFill>
+                <a:srgbClr val="1F2937"/>
+              </a:solidFill>
+              <a:latin typeface="Aptos"/>
+            </a:endParaRPr>
           </a:p>
           <a:p>
             <a:pPr algn="l"/>
@@ -5818,15 +5797,12 @@
           </a:p>
           <a:p>
             <a:pPr algn="l"/>
-            <a:r>
-              <a:rPr sz="1050">
-                <a:solidFill>
-                  <a:srgbClr val="1F2937"/>
-                </a:solidFill>
-                <a:latin typeface="Aptos"/>
-              </a:rPr>
-              <a:t/>
-            </a:r>
+            <a:endParaRPr sz="1050">
+              <a:solidFill>
+                <a:srgbClr val="1F2937"/>
+              </a:solidFill>
+              <a:latin typeface="Aptos"/>
+            </a:endParaRPr>
           </a:p>
           <a:p>
             <a:pPr algn="l"/>
@@ -5898,7 +5874,7 @@
 </file>
 
 <file path=ppt/slides/slide13.xml><?xml version="1.0" encoding="utf-8"?>
-<p:sld xmlns:a="http://schemas.openxmlformats.org/drawingml/2006/main" xmlns:p="http://schemas.openxmlformats.org/presentationml/2006/main" xmlns:r="http://schemas.openxmlformats.org/officeDocument/2006/relationships">
+<p:sld xmlns:a="http://schemas.openxmlformats.org/drawingml/2006/main" xmlns:r="http://schemas.openxmlformats.org/officeDocument/2006/relationships" xmlns:p="http://schemas.openxmlformats.org/presentationml/2006/main">
   <p:cSld>
     <p:bg>
       <p:bgPr>
@@ -5914,7 +5890,14 @@
         <p:cNvGrpSpPr/>
         <p:nvPr/>
       </p:nvGrpSpPr>
-      <p:grpSpPr/>
+      <p:grpSpPr>
+        <a:xfrm>
+          <a:off x="0" y="0"/>
+          <a:ext cx="0" cy="0"/>
+          <a:chOff x="0" y="0"/>
+          <a:chExt cx="0" cy="0"/>
+        </a:xfrm>
+      </p:grpSpPr>
       <p:sp>
         <p:nvSpPr>
           <p:cNvPr id="2" name="TextBox 1"/>
@@ -6002,6 +5985,7 @@
           <a:lstStyle/>
           <a:p>
             <a:pPr algn="ctr"/>
+            <a:endParaRPr/>
           </a:p>
         </p:txBody>
       </p:sp>
@@ -6240,7 +6224,7 @@
 </file>
 
 <file path=ppt/slides/slide2.xml><?xml version="1.0" encoding="utf-8"?>
-<p:sld xmlns:a="http://schemas.openxmlformats.org/drawingml/2006/main" xmlns:p="http://schemas.openxmlformats.org/presentationml/2006/main" xmlns:r="http://schemas.openxmlformats.org/officeDocument/2006/relationships">
+<p:sld xmlns:a="http://schemas.openxmlformats.org/drawingml/2006/main" xmlns:r="http://schemas.openxmlformats.org/officeDocument/2006/relationships" xmlns:p="http://schemas.openxmlformats.org/presentationml/2006/main">
   <p:cSld>
     <p:bg>
       <p:bgPr>
@@ -6256,7 +6240,14 @@
         <p:cNvGrpSpPr/>
         <p:nvPr/>
       </p:nvGrpSpPr>
-      <p:grpSpPr/>
+      <p:grpSpPr>
+        <a:xfrm>
+          <a:off x="0" y="0"/>
+          <a:ext cx="0" cy="0"/>
+          <a:chOff x="0" y="0"/>
+          <a:chExt cx="0" cy="0"/>
+        </a:xfrm>
+      </p:grpSpPr>
       <p:sp>
         <p:nvSpPr>
           <p:cNvPr id="2" name="TextBox 1"/>
@@ -6344,6 +6335,7 @@
           <a:lstStyle/>
           <a:p>
             <a:pPr algn="ctr"/>
+            <a:endParaRPr/>
           </a:p>
         </p:txBody>
       </p:sp>
@@ -6502,6 +6494,7 @@
           <a:lstStyle/>
           <a:p>
             <a:pPr algn="ctr"/>
+            <a:endParaRPr/>
           </a:p>
         </p:txBody>
       </p:sp>
@@ -6648,6 +6641,7 @@
           <a:lstStyle/>
           <a:p>
             <a:pPr algn="ctr"/>
+            <a:endParaRPr/>
           </a:p>
         </p:txBody>
       </p:sp>
@@ -6794,6 +6788,7 @@
           <a:lstStyle/>
           <a:p>
             <a:pPr algn="ctr"/>
+            <a:endParaRPr/>
           </a:p>
         </p:txBody>
       </p:sp>
@@ -7020,7 +7015,7 @@
 </file>
 
 <file path=ppt/slides/slide3.xml><?xml version="1.0" encoding="utf-8"?>
-<p:sld xmlns:a="http://schemas.openxmlformats.org/drawingml/2006/main" xmlns:p="http://schemas.openxmlformats.org/presentationml/2006/main" xmlns:r="http://schemas.openxmlformats.org/officeDocument/2006/relationships">
+<p:sld xmlns:a="http://schemas.openxmlformats.org/drawingml/2006/main" xmlns:r="http://schemas.openxmlformats.org/officeDocument/2006/relationships" xmlns:p="http://schemas.openxmlformats.org/presentationml/2006/main">
   <p:cSld>
     <p:bg>
       <p:bgPr>
@@ -7036,7 +7031,14 @@
         <p:cNvGrpSpPr/>
         <p:nvPr/>
       </p:nvGrpSpPr>
-      <p:grpSpPr/>
+      <p:grpSpPr>
+        <a:xfrm>
+          <a:off x="0" y="0"/>
+          <a:ext cx="0" cy="0"/>
+          <a:chOff x="0" y="0"/>
+          <a:chExt cx="0" cy="0"/>
+        </a:xfrm>
+      </p:grpSpPr>
       <p:sp>
         <p:nvSpPr>
           <p:cNvPr id="2" name="TextBox 1"/>
@@ -7091,7 +7093,7 @@
         <p:spPr>
           <a:xfrm>
             <a:off x="594360" y="1325880"/>
-            <a:ext cx="10972800" cy="685800"/>
+            <a:ext cx="10972800" cy="822960"/>
           </a:xfrm>
           <a:prstGeom prst="roundRect">
             <a:avLst/>
@@ -7124,6 +7126,7 @@
           <a:lstStyle/>
           <a:p>
             <a:pPr algn="ctr"/>
+            <a:endParaRPr/>
           </a:p>
         </p:txBody>
       </p:sp>
@@ -7205,13 +7208,31 @@
           <a:p>
             <a:pPr algn="l"/>
             <a:r>
-              <a:rPr sz="1050">
-                <a:solidFill>
-                  <a:srgbClr val="1F2937"/>
-                </a:solidFill>
-                <a:latin typeface="Aptos"/>
-              </a:rPr>
-              <a:t>Layer 0: protocols and types. Layer 1: memory and skills. Layer 2: harness, graders, tracing. Layer 3: evolution utilities. The application code in `src/` sits above this and supplies the domain-specific agent factory, prompts, tools, and CLI.</a:t>
+              <a:rPr sz="1050" dirty="0">
+                <a:solidFill>
+                  <a:srgbClr val="1F2937"/>
+                </a:solidFill>
+                <a:latin typeface="Aptos"/>
+              </a:rPr>
+              <a:t>Layer 0: protocols and types. Layer 1: memory and skills. Layer 2: harness, graders, tracing. Layer 3: evolution utilities. The application code in `</a:t>
+            </a:r>
+            <a:r>
+              <a:rPr sz="1050" dirty="0" err="1">
+                <a:solidFill>
+                  <a:srgbClr val="1F2937"/>
+                </a:solidFill>
+                <a:latin typeface="Aptos"/>
+              </a:rPr>
+              <a:t>src</a:t>
+            </a:r>
+            <a:r>
+              <a:rPr sz="1050" dirty="0">
+                <a:solidFill>
+                  <a:srgbClr val="1F2937"/>
+                </a:solidFill>
+                <a:latin typeface="Aptos"/>
+              </a:rPr>
+              <a:t>/` sits above this and supplies the domain-specific agent factory, prompts, tools, and CLI.</a:t>
             </a:r>
           </a:p>
         </p:txBody>
@@ -7587,7 +7608,7 @@
         </p:nvSpPr>
         <p:spPr>
           <a:xfrm>
-            <a:off x="502920" y="6400800"/>
+            <a:off x="502920" y="6421820"/>
             <a:ext cx="10972800" cy="274320"/>
           </a:xfrm>
           <a:prstGeom prst="rect">
@@ -7623,7 +7644,7 @@
 </file>
 
 <file path=ppt/slides/slide4.xml><?xml version="1.0" encoding="utf-8"?>
-<p:sld xmlns:a="http://schemas.openxmlformats.org/drawingml/2006/main" xmlns:p="http://schemas.openxmlformats.org/presentationml/2006/main" xmlns:r="http://schemas.openxmlformats.org/officeDocument/2006/relationships">
+<p:sld xmlns:a="http://schemas.openxmlformats.org/drawingml/2006/main" xmlns:r="http://schemas.openxmlformats.org/officeDocument/2006/relationships" xmlns:p="http://schemas.openxmlformats.org/presentationml/2006/main">
   <p:cSld>
     <p:bg>
       <p:bgPr>
@@ -7639,7 +7660,14 @@
         <p:cNvGrpSpPr/>
         <p:nvPr/>
       </p:nvGrpSpPr>
-      <p:grpSpPr/>
+      <p:grpSpPr>
+        <a:xfrm>
+          <a:off x="0" y="0"/>
+          <a:ext cx="0" cy="0"/>
+          <a:chOff x="0" y="0"/>
+          <a:chExt cx="0" cy="0"/>
+        </a:xfrm>
+      </p:grpSpPr>
       <p:sp>
         <p:nvSpPr>
           <p:cNvPr id="2" name="TextBox 1"/>
@@ -7727,6 +7755,7 @@
           <a:lstStyle/>
           <a:p>
             <a:pPr algn="ctr"/>
+            <a:endParaRPr/>
           </a:p>
         </p:txBody>
       </p:sp>
@@ -7873,15 +7902,7 @@
           <a:lstStyle/>
           <a:p>
             <a:pPr algn="ctr"/>
-            <a:r>
-              <a:rPr sz="1000">
-                <a:solidFill>
-                  <a:srgbClr val="4C5B6A"/>
-                </a:solidFill>
-                <a:latin typeface="Aptos"/>
-              </a:rPr>
-              <a:t/>
-            </a:r>
+            <a:endParaRPr/>
           </a:p>
         </p:txBody>
       </p:sp>
@@ -7927,6 +7948,7 @@
           <a:lstStyle/>
           <a:p>
             <a:pPr algn="ctr"/>
+            <a:endParaRPr/>
           </a:p>
         </p:txBody>
       </p:sp>
@@ -8086,15 +8108,7 @@
           <a:lstStyle/>
           <a:p>
             <a:pPr algn="ctr"/>
-            <a:r>
-              <a:rPr sz="1000">
-                <a:solidFill>
-                  <a:srgbClr val="4C5B6A"/>
-                </a:solidFill>
-                <a:latin typeface="Aptos"/>
-              </a:rPr>
-              <a:t/>
-            </a:r>
+            <a:endParaRPr/>
           </a:p>
         </p:txBody>
       </p:sp>
@@ -8140,6 +8154,7 @@
           <a:lstStyle/>
           <a:p>
             <a:pPr algn="ctr"/>
+            <a:endParaRPr/>
           </a:p>
         </p:txBody>
       </p:sp>
@@ -8298,15 +8313,7 @@
           <a:lstStyle/>
           <a:p>
             <a:pPr algn="ctr"/>
-            <a:r>
-              <a:rPr sz="1000">
-                <a:solidFill>
-                  <a:srgbClr val="4C5B6A"/>
-                </a:solidFill>
-                <a:latin typeface="Aptos"/>
-              </a:rPr>
-              <a:t/>
-            </a:r>
+            <a:endParaRPr/>
           </a:p>
         </p:txBody>
       </p:sp>
@@ -8352,6 +8359,7 @@
           <a:lstStyle/>
           <a:p>
             <a:pPr algn="ctr"/>
+            <a:endParaRPr/>
           </a:p>
         </p:txBody>
       </p:sp>
@@ -8531,15 +8539,12 @@
             </a:r>
           </a:p>
           <a:p>
-            <a:r>
-              <a:rPr sz="1050">
-                <a:solidFill>
-                  <a:srgbClr val="1F2937"/>
-                </a:solidFill>
-                <a:latin typeface="Aptos"/>
-              </a:rPr>
-              <a:t/>
-            </a:r>
+            <a:endParaRPr sz="1050">
+              <a:solidFill>
+                <a:srgbClr val="1F2937"/>
+              </a:solidFill>
+              <a:latin typeface="Aptos"/>
+            </a:endParaRPr>
           </a:p>
           <a:p>
             <a:r>
@@ -8761,7 +8766,7 @@
 </file>
 
 <file path=ppt/slides/slide5.xml><?xml version="1.0" encoding="utf-8"?>
-<p:sld xmlns:a="http://schemas.openxmlformats.org/drawingml/2006/main" xmlns:p="http://schemas.openxmlformats.org/presentationml/2006/main" xmlns:r="http://schemas.openxmlformats.org/officeDocument/2006/relationships">
+<p:sld xmlns:a="http://schemas.openxmlformats.org/drawingml/2006/main" xmlns:r="http://schemas.openxmlformats.org/officeDocument/2006/relationships" xmlns:p="http://schemas.openxmlformats.org/presentationml/2006/main">
   <p:cSld>
     <p:bg>
       <p:bgPr>
@@ -8777,7 +8782,14 @@
         <p:cNvGrpSpPr/>
         <p:nvPr/>
       </p:nvGrpSpPr>
-      <p:grpSpPr/>
+      <p:grpSpPr>
+        <a:xfrm>
+          <a:off x="0" y="0"/>
+          <a:ext cx="0" cy="0"/>
+          <a:chOff x="0" y="0"/>
+          <a:chExt cx="0" cy="0"/>
+        </a:xfrm>
+      </p:grpSpPr>
       <p:sp>
         <p:nvSpPr>
           <p:cNvPr id="2" name="TextBox 1"/>
@@ -8930,15 +8942,7 @@
           <a:lstStyle/>
           <a:p>
             <a:pPr algn="ctr"/>
-            <a:r>
-              <a:rPr sz="1000">
-                <a:solidFill>
-                  <a:srgbClr val="4C5B6A"/>
-                </a:solidFill>
-                <a:latin typeface="Aptos"/>
-              </a:rPr>
-              <a:t/>
-            </a:r>
+            <a:endParaRPr/>
           </a:p>
         </p:txBody>
       </p:sp>
@@ -9049,15 +9053,7 @@
           <a:lstStyle/>
           <a:p>
             <a:pPr algn="ctr"/>
-            <a:r>
-              <a:rPr sz="1000">
-                <a:solidFill>
-                  <a:srgbClr val="4C5B6A"/>
-                </a:solidFill>
-                <a:latin typeface="Aptos"/>
-              </a:rPr>
-              <a:t/>
-            </a:r>
+            <a:endParaRPr/>
           </a:p>
         </p:txBody>
       </p:sp>
@@ -9168,15 +9164,7 @@
           <a:lstStyle/>
           <a:p>
             <a:pPr algn="ctr"/>
-            <a:r>
-              <a:rPr sz="1000">
-                <a:solidFill>
-                  <a:srgbClr val="4C5B6A"/>
-                </a:solidFill>
-                <a:latin typeface="Aptos"/>
-              </a:rPr>
-              <a:t/>
-            </a:r>
+            <a:endParaRPr/>
           </a:p>
         </p:txBody>
       </p:sp>
@@ -9287,15 +9275,7 @@
           <a:lstStyle/>
           <a:p>
             <a:pPr algn="ctr"/>
-            <a:r>
-              <a:rPr sz="1000">
-                <a:solidFill>
-                  <a:srgbClr val="4C5B6A"/>
-                </a:solidFill>
-                <a:latin typeface="Aptos"/>
-              </a:rPr>
-              <a:t/>
-            </a:r>
+            <a:endParaRPr/>
           </a:p>
         </p:txBody>
       </p:sp>
@@ -9406,15 +9386,7 @@
           <a:lstStyle/>
           <a:p>
             <a:pPr algn="ctr"/>
-            <a:r>
-              <a:rPr sz="1000">
-                <a:solidFill>
-                  <a:srgbClr val="4C5B6A"/>
-                </a:solidFill>
-                <a:latin typeface="Aptos"/>
-              </a:rPr>
-              <a:t/>
-            </a:r>
+            <a:endParaRPr/>
           </a:p>
         </p:txBody>
       </p:sp>
@@ -9525,6 +9497,7 @@
           <a:lstStyle/>
           <a:p>
             <a:pPr algn="ctr"/>
+            <a:endParaRPr/>
           </a:p>
         </p:txBody>
       </p:sp>
@@ -9661,7 +9634,7 @@
 </file>
 
 <file path=ppt/slides/slide6.xml><?xml version="1.0" encoding="utf-8"?>
-<p:sld xmlns:a="http://schemas.openxmlformats.org/drawingml/2006/main" xmlns:p="http://schemas.openxmlformats.org/presentationml/2006/main" xmlns:r="http://schemas.openxmlformats.org/officeDocument/2006/relationships">
+<p:sld xmlns:a="http://schemas.openxmlformats.org/drawingml/2006/main" xmlns:r="http://schemas.openxmlformats.org/officeDocument/2006/relationships" xmlns:p="http://schemas.openxmlformats.org/presentationml/2006/main">
   <p:cSld>
     <p:bg>
       <p:bgPr>
@@ -9677,7 +9650,14 @@
         <p:cNvGrpSpPr/>
         <p:nvPr/>
       </p:nvGrpSpPr>
-      <p:grpSpPr/>
+      <p:grpSpPr>
+        <a:xfrm>
+          <a:off x="0" y="0"/>
+          <a:ext cx="0" cy="0"/>
+          <a:chOff x="0" y="0"/>
+          <a:chExt cx="0" cy="0"/>
+        </a:xfrm>
+      </p:grpSpPr>
       <p:sp>
         <p:nvSpPr>
           <p:cNvPr id="2" name="TextBox 1"/>
@@ -9732,7 +9712,7 @@
         <p:spPr>
           <a:xfrm>
             <a:off x="502920" y="1463040"/>
-            <a:ext cx="1828800" cy="914400"/>
+            <a:ext cx="1828800" cy="1154036"/>
           </a:xfrm>
           <a:prstGeom prst="roundRect">
             <a:avLst/>
@@ -9765,6 +9745,7 @@
           <a:lstStyle/>
           <a:p>
             <a:pPr algn="ctr"/>
+            <a:endParaRPr/>
           </a:p>
         </p:txBody>
       </p:sp>
@@ -9899,15 +9880,7 @@
           <a:lstStyle/>
           <a:p>
             <a:pPr algn="ctr"/>
-            <a:r>
-              <a:rPr sz="1000">
-                <a:solidFill>
-                  <a:srgbClr val="4C5B6A"/>
-                </a:solidFill>
-                <a:latin typeface="Aptos"/>
-              </a:rPr>
-              <a:t/>
-            </a:r>
+            <a:endParaRPr/>
           </a:p>
         </p:txBody>
       </p:sp>
@@ -9919,8 +9892,8 @@
         </p:nvSpPr>
         <p:spPr>
           <a:xfrm>
-            <a:off x="3017520" y="1463040"/>
-            <a:ext cx="1828800" cy="914400"/>
+            <a:off x="3017520" y="1463039"/>
+            <a:ext cx="1828800" cy="1154035"/>
           </a:xfrm>
           <a:prstGeom prst="roundRect">
             <a:avLst/>
@@ -9953,6 +9926,7 @@
           <a:lstStyle/>
           <a:p>
             <a:pPr algn="ctr"/>
+            <a:endParaRPr/>
           </a:p>
         </p:txBody>
       </p:sp>
@@ -10087,15 +10061,7 @@
           <a:lstStyle/>
           <a:p>
             <a:pPr algn="ctr"/>
-            <a:r>
-              <a:rPr sz="1000">
-                <a:solidFill>
-                  <a:srgbClr val="4C5B6A"/>
-                </a:solidFill>
-                <a:latin typeface="Aptos"/>
-              </a:rPr>
-              <a:t/>
-            </a:r>
+            <a:endParaRPr/>
           </a:p>
         </p:txBody>
       </p:sp>
@@ -10108,7 +10074,7 @@
         <p:spPr>
           <a:xfrm>
             <a:off x="5532120" y="1463040"/>
-            <a:ext cx="1828800" cy="914400"/>
+            <a:ext cx="1828800" cy="1280160"/>
           </a:xfrm>
           <a:prstGeom prst="roundRect">
             <a:avLst/>
@@ -10141,6 +10107,7 @@
           <a:lstStyle/>
           <a:p>
             <a:pPr algn="ctr"/>
+            <a:endParaRPr/>
           </a:p>
         </p:txBody>
       </p:sp>
@@ -10275,15 +10242,7 @@
           <a:lstStyle/>
           <a:p>
             <a:pPr algn="ctr"/>
-            <a:r>
-              <a:rPr sz="1000">
-                <a:solidFill>
-                  <a:srgbClr val="4C5B6A"/>
-                </a:solidFill>
-                <a:latin typeface="Aptos"/>
-              </a:rPr>
-              <a:t/>
-            </a:r>
+            <a:endParaRPr/>
           </a:p>
         </p:txBody>
       </p:sp>
@@ -10296,7 +10255,7 @@
         <p:spPr>
           <a:xfrm>
             <a:off x="8046720" y="1463040"/>
-            <a:ext cx="1828800" cy="914400"/>
+            <a:ext cx="1828800" cy="1154034"/>
           </a:xfrm>
           <a:prstGeom prst="roundRect">
             <a:avLst/>
@@ -10329,6 +10288,7 @@
           <a:lstStyle/>
           <a:p>
             <a:pPr algn="ctr"/>
+            <a:endParaRPr/>
           </a:p>
         </p:txBody>
       </p:sp>
@@ -10463,15 +10423,7 @@
           <a:lstStyle/>
           <a:p>
             <a:pPr algn="ctr"/>
-            <a:r>
-              <a:rPr sz="1000">
-                <a:solidFill>
-                  <a:srgbClr val="4C5B6A"/>
-                </a:solidFill>
-                <a:latin typeface="Aptos"/>
-              </a:rPr>
-              <a:t/>
-            </a:r>
+            <a:endParaRPr/>
           </a:p>
         </p:txBody>
       </p:sp>
@@ -10483,8 +10435,8 @@
         </p:nvSpPr>
         <p:spPr>
           <a:xfrm>
-            <a:off x="10561320" y="1463040"/>
-            <a:ext cx="1143000" cy="914400"/>
+            <a:off x="10561320" y="1463039"/>
+            <a:ext cx="1143000" cy="1154033"/>
           </a:xfrm>
           <a:prstGeom prst="roundRect">
             <a:avLst/>
@@ -10517,6 +10469,7 @@
           <a:lstStyle/>
           <a:p>
             <a:pPr algn="ctr"/>
+            <a:endParaRPr/>
           </a:p>
         </p:txBody>
       </p:sp>
@@ -10617,8 +10570,8 @@
         </p:nvSpPr>
         <p:spPr>
           <a:xfrm>
-            <a:off x="685800" y="2834640"/>
-            <a:ext cx="5394960" cy="2560320"/>
+            <a:off x="685800" y="3063240"/>
+            <a:ext cx="5394960" cy="2331720"/>
           </a:xfrm>
           <a:prstGeom prst="roundRect">
             <a:avLst/>
@@ -10673,15 +10626,12 @@
             </a:r>
           </a:p>
           <a:p>
-            <a:r>
-              <a:rPr sz="1050">
-                <a:solidFill>
-                  <a:srgbClr val="1F2937"/>
-                </a:solidFill>
-                <a:latin typeface="Aptos"/>
-              </a:rPr>
-              <a:t/>
-            </a:r>
+            <a:endParaRPr sz="1050">
+              <a:solidFill>
+                <a:srgbClr val="1F2937"/>
+              </a:solidFill>
+              <a:latin typeface="Aptos"/>
+            </a:endParaRPr>
           </a:p>
           <a:p>
             <a:r>
@@ -10695,15 +10645,12 @@
             </a:r>
           </a:p>
           <a:p>
-            <a:r>
-              <a:rPr sz="1050">
-                <a:solidFill>
-                  <a:srgbClr val="1F2937"/>
-                </a:solidFill>
-                <a:latin typeface="Aptos"/>
-              </a:rPr>
-              <a:t/>
-            </a:r>
+            <a:endParaRPr sz="1050">
+              <a:solidFill>
+                <a:srgbClr val="1F2937"/>
+              </a:solidFill>
+              <a:latin typeface="Aptos"/>
+            </a:endParaRPr>
           </a:p>
           <a:p>
             <a:r>
@@ -10748,8 +10695,8 @@
         </p:nvSpPr>
         <p:spPr>
           <a:xfrm>
-            <a:off x="6355080" y="2834640"/>
-            <a:ext cx="5166360" cy="2560320"/>
+            <a:off x="6355080" y="3063238"/>
+            <a:ext cx="5166360" cy="2331721"/>
           </a:xfrm>
           <a:prstGeom prst="roundRect">
             <a:avLst/>
@@ -10915,7 +10862,7 @@
 </file>
 
 <file path=ppt/slides/slide7.xml><?xml version="1.0" encoding="utf-8"?>
-<p:sld xmlns:a="http://schemas.openxmlformats.org/drawingml/2006/main" xmlns:p="http://schemas.openxmlformats.org/presentationml/2006/main" xmlns:r="http://schemas.openxmlformats.org/officeDocument/2006/relationships">
+<p:sld xmlns:a="http://schemas.openxmlformats.org/drawingml/2006/main" xmlns:r="http://schemas.openxmlformats.org/officeDocument/2006/relationships" xmlns:p="http://schemas.openxmlformats.org/presentationml/2006/main">
   <p:cSld>
     <p:bg>
       <p:bgPr>
@@ -10931,7 +10878,14 @@
         <p:cNvGrpSpPr/>
         <p:nvPr/>
       </p:nvGrpSpPr>
-      <p:grpSpPr/>
+      <p:grpSpPr>
+        <a:xfrm>
+          <a:off x="0" y="0"/>
+          <a:ext cx="0" cy="0"/>
+          <a:chOff x="0" y="0"/>
+          <a:chExt cx="0" cy="0"/>
+        </a:xfrm>
+      </p:grpSpPr>
       <p:sp>
         <p:nvSpPr>
           <p:cNvPr id="2" name="TextBox 1"/>
@@ -11019,6 +10973,7 @@
           <a:lstStyle/>
           <a:p>
             <a:pPr algn="ctr"/>
+            <a:endParaRPr/>
           </a:p>
         </p:txBody>
       </p:sp>
@@ -11165,15 +11120,7 @@
           <a:lstStyle/>
           <a:p>
             <a:pPr algn="ctr"/>
-            <a:r>
-              <a:rPr sz="1000">
-                <a:solidFill>
-                  <a:srgbClr val="4C5B6A"/>
-                </a:solidFill>
-                <a:latin typeface="Aptos"/>
-              </a:rPr>
-              <a:t/>
-            </a:r>
+            <a:endParaRPr/>
           </a:p>
         </p:txBody>
       </p:sp>
@@ -11219,6 +11166,7 @@
           <a:lstStyle/>
           <a:p>
             <a:pPr algn="ctr"/>
+            <a:endParaRPr/>
           </a:p>
         </p:txBody>
       </p:sp>
@@ -11377,15 +11325,7 @@
           <a:lstStyle/>
           <a:p>
             <a:pPr algn="ctr"/>
-            <a:r>
-              <a:rPr sz="1000">
-                <a:solidFill>
-                  <a:srgbClr val="4C5B6A"/>
-                </a:solidFill>
-                <a:latin typeface="Aptos"/>
-              </a:rPr>
-              <a:t/>
-            </a:r>
+            <a:endParaRPr/>
           </a:p>
         </p:txBody>
       </p:sp>
@@ -11431,6 +11371,7 @@
           <a:lstStyle/>
           <a:p>
             <a:pPr algn="ctr"/>
+            <a:endParaRPr/>
           </a:p>
         </p:txBody>
       </p:sp>
@@ -11565,15 +11506,7 @@
           <a:lstStyle/>
           <a:p>
             <a:pPr algn="ctr"/>
-            <a:r>
-              <a:rPr sz="1000">
-                <a:solidFill>
-                  <a:srgbClr val="4C5B6A"/>
-                </a:solidFill>
-                <a:latin typeface="Aptos"/>
-              </a:rPr>
-              <a:t/>
-            </a:r>
+            <a:endParaRPr/>
           </a:p>
         </p:txBody>
       </p:sp>
@@ -11619,6 +11552,7 @@
           <a:lstStyle/>
           <a:p>
             <a:pPr algn="ctr"/>
+            <a:endParaRPr/>
           </a:p>
         </p:txBody>
       </p:sp>
@@ -11753,15 +11687,7 @@
           <a:lstStyle/>
           <a:p>
             <a:pPr algn="ctr"/>
-            <a:r>
-              <a:rPr sz="1000">
-                <a:solidFill>
-                  <a:srgbClr val="4C5B6A"/>
-                </a:solidFill>
-                <a:latin typeface="Aptos"/>
-              </a:rPr>
-              <a:t/>
-            </a:r>
+            <a:endParaRPr/>
           </a:p>
         </p:txBody>
       </p:sp>
@@ -11807,6 +11733,7 @@
           <a:lstStyle/>
           <a:p>
             <a:pPr algn="ctr"/>
+            <a:endParaRPr/>
           </a:p>
         </p:txBody>
       </p:sp>
@@ -11907,8 +11834,8 @@
         </p:nvSpPr>
         <p:spPr>
           <a:xfrm>
-            <a:off x="1051560" y="3246120"/>
-            <a:ext cx="10058400" cy="1965960"/>
+            <a:off x="1030276" y="3191257"/>
+            <a:ext cx="10131447" cy="1965960"/>
           </a:xfrm>
           <a:prstGeom prst="roundRect">
             <a:avLst/>
@@ -11941,6 +11868,7 @@
           <a:lstStyle/>
           <a:p>
             <a:pPr algn="ctr"/>
+            <a:endParaRPr/>
           </a:p>
         </p:txBody>
       </p:sp>
@@ -12045,15 +11973,12 @@
           </a:p>
           <a:p>
             <a:pPr algn="l"/>
-            <a:r>
-              <a:rPr sz="1050">
-                <a:solidFill>
-                  <a:srgbClr val="1F2937"/>
-                </a:solidFill>
-                <a:latin typeface="Aptos"/>
-              </a:rPr>
-              <a:t/>
-            </a:r>
+            <a:endParaRPr sz="1050">
+              <a:solidFill>
+                <a:srgbClr val="1F2937"/>
+              </a:solidFill>
+              <a:latin typeface="Aptos"/>
+            </a:endParaRPr>
           </a:p>
           <a:p>
             <a:pPr algn="l"/>
@@ -12113,7 +12038,7 @@
 </file>
 
 <file path=ppt/slides/slide8.xml><?xml version="1.0" encoding="utf-8"?>
-<p:sld xmlns:a="http://schemas.openxmlformats.org/drawingml/2006/main" xmlns:p="http://schemas.openxmlformats.org/presentationml/2006/main" xmlns:r="http://schemas.openxmlformats.org/officeDocument/2006/relationships">
+<p:sld xmlns:a="http://schemas.openxmlformats.org/drawingml/2006/main" xmlns:r="http://schemas.openxmlformats.org/officeDocument/2006/relationships" xmlns:p="http://schemas.openxmlformats.org/presentationml/2006/main">
   <p:cSld>
     <p:bg>
       <p:bgPr>
@@ -12129,7 +12054,14 @@
         <p:cNvGrpSpPr/>
         <p:nvPr/>
       </p:nvGrpSpPr>
-      <p:grpSpPr/>
+      <p:grpSpPr>
+        <a:xfrm>
+          <a:off x="0" y="0"/>
+          <a:ext cx="0" cy="0"/>
+          <a:chOff x="0" y="0"/>
+          <a:chExt cx="0" cy="0"/>
+        </a:xfrm>
+      </p:grpSpPr>
       <p:sp>
         <p:nvSpPr>
           <p:cNvPr id="2" name="TextBox 1"/>
@@ -12184,7 +12116,7 @@
         <p:spPr>
           <a:xfrm>
             <a:off x="594360" y="1371600"/>
-            <a:ext cx="2743200" cy="1508760"/>
+            <a:ext cx="2743200" cy="1697420"/>
           </a:xfrm>
           <a:prstGeom prst="roundRect">
             <a:avLst/>
@@ -12217,6 +12149,7 @@
           <a:lstStyle/>
           <a:p>
             <a:pPr algn="ctr"/>
+            <a:endParaRPr/>
           </a:p>
         </p:txBody>
       </p:sp>
@@ -12341,8 +12274,8 @@
         </p:nvSpPr>
         <p:spPr>
           <a:xfrm>
-            <a:off x="3611880" y="1371600"/>
-            <a:ext cx="2743200" cy="1508760"/>
+            <a:off x="3611880" y="1371599"/>
+            <a:ext cx="2743200" cy="1697421"/>
           </a:xfrm>
           <a:prstGeom prst="roundRect">
             <a:avLst/>
@@ -12375,6 +12308,7 @@
           <a:lstStyle/>
           <a:p>
             <a:pPr algn="ctr"/>
+            <a:endParaRPr/>
           </a:p>
         </p:txBody>
       </p:sp>
@@ -12536,7 +12470,7 @@
         <p:spPr>
           <a:xfrm>
             <a:off x="6629400" y="1371600"/>
-            <a:ext cx="2194560" cy="1508760"/>
+            <a:ext cx="2194560" cy="1697420"/>
           </a:xfrm>
           <a:prstGeom prst="roundRect">
             <a:avLst/>
@@ -12569,6 +12503,7 @@
           <a:lstStyle/>
           <a:p>
             <a:pPr algn="ctr"/>
+            <a:endParaRPr/>
           </a:p>
         </p:txBody>
       </p:sp>
@@ -12705,8 +12640,8 @@
         </p:nvSpPr>
         <p:spPr>
           <a:xfrm>
-            <a:off x="9098280" y="1371600"/>
-            <a:ext cx="2194560" cy="1508760"/>
+            <a:off x="9098280" y="1371599"/>
+            <a:ext cx="2194560" cy="1697419"/>
           </a:xfrm>
           <a:prstGeom prst="roundRect">
             <a:avLst/>
@@ -12739,6 +12674,7 @@
           <a:lstStyle/>
           <a:p>
             <a:pPr algn="ctr"/>
+            <a:endParaRPr/>
           </a:p>
         </p:txBody>
       </p:sp>
@@ -12906,15 +12842,12 @@
             </a:r>
           </a:p>
           <a:p>
-            <a:r>
-              <a:rPr sz="1050">
-                <a:solidFill>
-                  <a:srgbClr val="1F2937"/>
-                </a:solidFill>
-                <a:latin typeface="Aptos"/>
-              </a:rPr>
-              <a:t/>
-            </a:r>
+            <a:endParaRPr sz="1050">
+              <a:solidFill>
+                <a:srgbClr val="1F2937"/>
+              </a:solidFill>
+              <a:latin typeface="Aptos"/>
+            </a:endParaRPr>
           </a:p>
           <a:p>
             <a:r>
@@ -12939,15 +12872,12 @@
             </a:r>
           </a:p>
           <a:p>
-            <a:r>
-              <a:rPr sz="1050">
-                <a:solidFill>
-                  <a:srgbClr val="1F2937"/>
-                </a:solidFill>
-                <a:latin typeface="Aptos"/>
-              </a:rPr>
-              <a:t/>
-            </a:r>
+            <a:endParaRPr sz="1050">
+              <a:solidFill>
+                <a:srgbClr val="1F2937"/>
+              </a:solidFill>
+              <a:latin typeface="Aptos"/>
+            </a:endParaRPr>
           </a:p>
           <a:p>
             <a:r>
@@ -13006,7 +12936,7 @@
 </file>
 
 <file path=ppt/slides/slide9.xml><?xml version="1.0" encoding="utf-8"?>
-<p:sld xmlns:a="http://schemas.openxmlformats.org/drawingml/2006/main" xmlns:p="http://schemas.openxmlformats.org/presentationml/2006/main" xmlns:r="http://schemas.openxmlformats.org/officeDocument/2006/relationships">
+<p:sld xmlns:a="http://schemas.openxmlformats.org/drawingml/2006/main" xmlns:r="http://schemas.openxmlformats.org/officeDocument/2006/relationships" xmlns:p="http://schemas.openxmlformats.org/presentationml/2006/main">
   <p:cSld>
     <p:bg>
       <p:bgPr>
@@ -13022,7 +12952,14 @@
         <p:cNvGrpSpPr/>
         <p:nvPr/>
       </p:nvGrpSpPr>
-      <p:grpSpPr/>
+      <p:grpSpPr>
+        <a:xfrm>
+          <a:off x="0" y="0"/>
+          <a:ext cx="0" cy="0"/>
+          <a:chOff x="0" y="0"/>
+          <a:chExt cx="0" cy="0"/>
+        </a:xfrm>
+      </p:grpSpPr>
       <p:sp>
         <p:nvSpPr>
           <p:cNvPr id="2" name="TextBox 1"/>
@@ -13077,7 +13014,7 @@
         <p:spPr>
           <a:xfrm>
             <a:off x="502920" y="1417320"/>
-            <a:ext cx="2788920" cy="1737360"/>
+            <a:ext cx="2788920" cy="2011680"/>
           </a:xfrm>
           <a:prstGeom prst="roundRect">
             <a:avLst/>
@@ -13110,6 +13047,7 @@
           <a:lstStyle/>
           <a:p>
             <a:pPr algn="ctr"/>
+            <a:endParaRPr/>
           </a:p>
         </p:txBody>
       </p:sp>
@@ -13247,7 +13185,7 @@
         <p:spPr>
           <a:xfrm>
             <a:off x="3520440" y="1417320"/>
-            <a:ext cx="2788920" cy="1737360"/>
+            <a:ext cx="2788920" cy="2011680"/>
           </a:xfrm>
           <a:prstGeom prst="roundRect">
             <a:avLst/>
@@ -13280,6 +13218,7 @@
           <a:lstStyle/>
           <a:p>
             <a:pPr algn="ctr"/>
+            <a:endParaRPr/>
           </a:p>
         </p:txBody>
       </p:sp>
@@ -13405,7 +13344,7 @@
         <p:spPr>
           <a:xfrm>
             <a:off x="6537960" y="1417320"/>
-            <a:ext cx="2514600" cy="1737360"/>
+            <a:ext cx="2514600" cy="2011680"/>
           </a:xfrm>
           <a:prstGeom prst="roundRect">
             <a:avLst/>
@@ -13438,6 +13377,7 @@
           <a:lstStyle/>
           <a:p>
             <a:pPr algn="ctr"/>
+            <a:endParaRPr/>
           </a:p>
         </p:txBody>
       </p:sp>
@@ -13551,7 +13491,7 @@
         <p:spPr>
           <a:xfrm>
             <a:off x="9281160" y="1417320"/>
-            <a:ext cx="2331720" cy="1737360"/>
+            <a:ext cx="2331720" cy="2011680"/>
           </a:xfrm>
           <a:prstGeom prst="roundRect">
             <a:avLst/>
@@ -13584,6 +13524,7 @@
           <a:lstStyle/>
           <a:p>
             <a:pPr algn="ctr"/>
+            <a:endParaRPr/>
           </a:p>
         </p:txBody>
       </p:sp>
@@ -13718,6 +13659,7 @@
           <a:lstStyle/>
           <a:p>
             <a:pPr algn="ctr"/>
+            <a:endParaRPr/>
           </a:p>
         </p:txBody>
       </p:sp>

</xml_diff>